<commit_message>
Update PV_logo.png with circular borders
</commit_message>
<xml_diff>
--- a/assets/images/PV_logo.pptx
+++ b/assets/images/PV_logo.pptx
@@ -104,6 +104,11 @@
       </a:defRPr>
     </a:lvl9pPr>
   </p:defaultTextStyle>
+  <p:extLst>
+    <p:ext uri="{EFAFB233-063F-42B5-8137-9DF3F51BA10A}">
+      <p15:sldGuideLst xmlns:p15="http://schemas.microsoft.com/office/powerpoint/2012/main"/>
+    </p:ext>
+  </p:extLst>
 </p:presentation>
 </file>
 
@@ -238,7 +243,7 @@
           <a:p>
             <a:fld id="{CB9327A6-6E4D-4D84-8288-EF901B68E2D9}" type="datetimeFigureOut">
               <a:rPr lang="en-IN" smtClean="0"/>
-              <a:t>22-09-2026</a:t>
+              <a:t>23-09-2026</a:t>
             </a:fld>
             <a:endParaRPr lang="en-IN"/>
           </a:p>
@@ -408,7 +413,7 @@
           <a:p>
             <a:fld id="{CB9327A6-6E4D-4D84-8288-EF901B68E2D9}" type="datetimeFigureOut">
               <a:rPr lang="en-IN" smtClean="0"/>
-              <a:t>22-09-2026</a:t>
+              <a:t>23-09-2026</a:t>
             </a:fld>
             <a:endParaRPr lang="en-IN"/>
           </a:p>
@@ -588,7 +593,7 @@
           <a:p>
             <a:fld id="{CB9327A6-6E4D-4D84-8288-EF901B68E2D9}" type="datetimeFigureOut">
               <a:rPr lang="en-IN" smtClean="0"/>
-              <a:t>22-09-2026</a:t>
+              <a:t>23-09-2026</a:t>
             </a:fld>
             <a:endParaRPr lang="en-IN"/>
           </a:p>
@@ -758,7 +763,7 @@
           <a:p>
             <a:fld id="{CB9327A6-6E4D-4D84-8288-EF901B68E2D9}" type="datetimeFigureOut">
               <a:rPr lang="en-IN" smtClean="0"/>
-              <a:t>22-09-2026</a:t>
+              <a:t>23-09-2026</a:t>
             </a:fld>
             <a:endParaRPr lang="en-IN"/>
           </a:p>
@@ -1004,7 +1009,7 @@
           <a:p>
             <a:fld id="{CB9327A6-6E4D-4D84-8288-EF901B68E2D9}" type="datetimeFigureOut">
               <a:rPr lang="en-IN" smtClean="0"/>
-              <a:t>22-09-2026</a:t>
+              <a:t>23-09-2026</a:t>
             </a:fld>
             <a:endParaRPr lang="en-IN"/>
           </a:p>
@@ -1236,7 +1241,7 @@
           <a:p>
             <a:fld id="{CB9327A6-6E4D-4D84-8288-EF901B68E2D9}" type="datetimeFigureOut">
               <a:rPr lang="en-IN" smtClean="0"/>
-              <a:t>22-09-2026</a:t>
+              <a:t>23-09-2026</a:t>
             </a:fld>
             <a:endParaRPr lang="en-IN"/>
           </a:p>
@@ -1603,7 +1608,7 @@
           <a:p>
             <a:fld id="{CB9327A6-6E4D-4D84-8288-EF901B68E2D9}" type="datetimeFigureOut">
               <a:rPr lang="en-IN" smtClean="0"/>
-              <a:t>22-09-2026</a:t>
+              <a:t>23-09-2026</a:t>
             </a:fld>
             <a:endParaRPr lang="en-IN"/>
           </a:p>
@@ -1721,7 +1726,7 @@
           <a:p>
             <a:fld id="{CB9327A6-6E4D-4D84-8288-EF901B68E2D9}" type="datetimeFigureOut">
               <a:rPr lang="en-IN" smtClean="0"/>
-              <a:t>22-09-2026</a:t>
+              <a:t>23-09-2026</a:t>
             </a:fld>
             <a:endParaRPr lang="en-IN"/>
           </a:p>
@@ -1816,7 +1821,7 @@
           <a:p>
             <a:fld id="{CB9327A6-6E4D-4D84-8288-EF901B68E2D9}" type="datetimeFigureOut">
               <a:rPr lang="en-IN" smtClean="0"/>
-              <a:t>22-09-2026</a:t>
+              <a:t>23-09-2026</a:t>
             </a:fld>
             <a:endParaRPr lang="en-IN"/>
           </a:p>
@@ -2093,7 +2098,7 @@
           <a:p>
             <a:fld id="{CB9327A6-6E4D-4D84-8288-EF901B68E2D9}" type="datetimeFigureOut">
               <a:rPr lang="en-IN" smtClean="0"/>
-              <a:t>22-09-2026</a:t>
+              <a:t>23-09-2026</a:t>
             </a:fld>
             <a:endParaRPr lang="en-IN"/>
           </a:p>
@@ -2350,7 +2355,7 @@
           <a:p>
             <a:fld id="{CB9327A6-6E4D-4D84-8288-EF901B68E2D9}" type="datetimeFigureOut">
               <a:rPr lang="en-IN" smtClean="0"/>
-              <a:t>22-09-2026</a:t>
+              <a:t>23-09-2026</a:t>
             </a:fld>
             <a:endParaRPr lang="en-IN"/>
           </a:p>
@@ -2563,7 +2568,7 @@
           <a:p>
             <a:fld id="{CB9327A6-6E4D-4D84-8288-EF901B68E2D9}" type="datetimeFigureOut">
               <a:rPr lang="en-IN" smtClean="0"/>
-              <a:t>22-09-2026</a:t>
+              <a:t>23-09-2026</a:t>
             </a:fld>
             <a:endParaRPr lang="en-IN"/>
           </a:p>
@@ -2954,14 +2959,6 @@
 <file path=ppt/slides/slide1.xml><?xml version="1.0" encoding="utf-8"?>
 <p:sld xmlns:a="http://schemas.openxmlformats.org/drawingml/2006/main" xmlns:r="http://schemas.openxmlformats.org/officeDocument/2006/relationships" xmlns:p="http://schemas.openxmlformats.org/presentationml/2006/main">
   <p:cSld>
-    <p:bg>
-      <p:bgPr>
-        <a:solidFill>
-          <a:schemeClr val="tx1"/>
-        </a:solidFill>
-        <a:effectLst/>
-      </p:bgPr>
-    </p:bg>
     <p:spTree>
       <p:nvGrpSpPr>
         <p:cNvPr id="1" name=""/>
@@ -2976,6 +2973,58 @@
           <a:chExt cx="0" cy="0"/>
         </a:xfrm>
       </p:grpSpPr>
+      <p:sp>
+        <p:nvSpPr>
+          <p:cNvPr id="2" name="Rectangle: Rounded Corners 1">
+            <a:extLst>
+              <a:ext uri="{FF2B5EF4-FFF2-40B4-BE49-F238E27FC236}">
+                <a16:creationId xmlns:a16="http://schemas.microsoft.com/office/drawing/2014/main" id="{66B8EB38-0CEA-8E24-0679-E1F488268DD9}"/>
+              </a:ext>
+            </a:extLst>
+          </p:cNvPr>
+          <p:cNvSpPr/>
+          <p:nvPr/>
+        </p:nvSpPr>
+        <p:spPr>
+          <a:xfrm>
+            <a:off x="0" y="0"/>
+            <a:ext cx="10799762" cy="10799762"/>
+          </a:xfrm>
+          <a:prstGeom prst="roundRect">
+            <a:avLst/>
+          </a:prstGeom>
+          <a:solidFill>
+            <a:schemeClr val="tx1"/>
+          </a:solidFill>
+          <a:ln>
+            <a:noFill/>
+          </a:ln>
+        </p:spPr>
+        <p:style>
+          <a:lnRef idx="2">
+            <a:schemeClr val="accent1">
+              <a:shade val="15000"/>
+            </a:schemeClr>
+          </a:lnRef>
+          <a:fillRef idx="1">
+            <a:schemeClr val="accent1"/>
+          </a:fillRef>
+          <a:effectRef idx="0">
+            <a:schemeClr val="accent1"/>
+          </a:effectRef>
+          <a:fontRef idx="minor">
+            <a:schemeClr val="lt1"/>
+          </a:fontRef>
+        </p:style>
+        <p:txBody>
+          <a:bodyPr rtlCol="0" anchor="ctr"/>
+          <a:lstStyle/>
+          <a:p>
+            <a:pPr algn="ctr"/>
+            <a:endParaRPr lang="en-IN"/>
+          </a:p>
+        </p:txBody>
+      </p:sp>
       <p:sp>
         <p:nvSpPr>
           <p:cNvPr id="5" name="TextBox 4">

</xml_diff>